<commit_message>
Fix architecture diagram: add output guardrail
</commit_message>
<xml_diff>
--- a/docs/parking_chatbot_stage1.pptx
+++ b/docs/parking_chatbot_stage1.pptx
@@ -5524,8 +5524,8 @@
         </p:blipFill>
         <p:spPr>
           <a:xfrm>
-            <a:off x="1911800" y="1435608"/>
-            <a:ext cx="8383638" cy="4718304"/>
+            <a:off x="1914307" y="1435608"/>
+            <a:ext cx="8378624" cy="4718304"/>
           </a:xfrm>
           <a:prstGeom prst="rect">
             <a:avLst/>

</xml_diff>